<commit_message>
Remove personal name from training materials
</commit_message>
<xml_diff>
--- a/deliverables/greenhouse-sentinel-operator-training.pptx
+++ b/deliverables/greenhouse-sentinel-operator-training.pptx
@@ -2,17 +2,17 @@
 <file path=ppt/presentation.xml><?xml version="1.0" encoding="utf-8"?>
 <p:presentation xmlns:p="http://schemas.openxmlformats.org/presentationml/2006/main">
   <p:sldMasterIdLst>
-    <p:sldMasterId xmlns:r="http://schemas.openxmlformats.org/officeDocument/2006/relationships" id="2147483648" r:id="Rea039871e5234c96"/>
+    <p:sldMasterId xmlns:r="http://schemas.openxmlformats.org/officeDocument/2006/relationships" id="2147483648" r:id="R07825d37752e4936"/>
   </p:sldMasterIdLst>
   <p:notesMasterIdLst>
-    <p:notesMasterId xmlns:r="http://schemas.openxmlformats.org/officeDocument/2006/relationships" r:id="R73e891f1787446f1"/>
+    <p:notesMasterId xmlns:r="http://schemas.openxmlformats.org/officeDocument/2006/relationships" r:id="Rfa571065537c4d95"/>
   </p:notesMasterIdLst>
   <p:sldIdLst>
-    <p:sldId xmlns:r="http://schemas.openxmlformats.org/officeDocument/2006/relationships" id="256" r:id="Rccd37be3cf3a4f19"/>
-    <p:sldId xmlns:r="http://schemas.openxmlformats.org/officeDocument/2006/relationships" id="257" r:id="Rd58cbda1606f446e"/>
-    <p:sldId xmlns:r="http://schemas.openxmlformats.org/officeDocument/2006/relationships" id="258" r:id="Ra241299281ce41eb"/>
-    <p:sldId xmlns:r="http://schemas.openxmlformats.org/officeDocument/2006/relationships" id="259" r:id="Rf8bccc89a13a40d4"/>
-    <p:sldId xmlns:r="http://schemas.openxmlformats.org/officeDocument/2006/relationships" id="260" r:id="R7acdfa437a5a46cc"/>
+    <p:sldId xmlns:r="http://schemas.openxmlformats.org/officeDocument/2006/relationships" id="256" r:id="Ref60dc58d95d485a"/>
+    <p:sldId xmlns:r="http://schemas.openxmlformats.org/officeDocument/2006/relationships" id="257" r:id="R5d9546a5e8ef4c9d"/>
+    <p:sldId xmlns:r="http://schemas.openxmlformats.org/officeDocument/2006/relationships" id="258" r:id="R7ec40012ed40423c"/>
+    <p:sldId xmlns:r="http://schemas.openxmlformats.org/officeDocument/2006/relationships" id="259" r:id="R0fb581018e0f46b5"/>
+    <p:sldId xmlns:r="http://schemas.openxmlformats.org/officeDocument/2006/relationships" id="260" r:id="R4dc1b3a0e9364fe9"/>
   </p:sldIdLst>
   <p:sldSz cx="12192000" cy="6858000"/>
   <p:notesSz cx="6858000" cy="9144000"/>
@@ -451,7 +451,7 @@
           </a:p>
           <a:p xmlns:a="http://schemas.openxmlformats.org/drawingml/2006/main">
             <a:r>
-              <a:t>- training/jays-book.json — deck title, sequence, and training framing.</a:t>
+              <a:t>- training/operator-training-book.json — deck title, sequence, and training framing.</a:t>
             </a:r>
           </a:p>
         </p:txBody>
@@ -751,7 +751,7 @@
           </a:p>
           <a:p xmlns:a="http://schemas.openxmlformats.org/drawingml/2006/main">
             <a:r>
-              <a:t>- training/jays-book.json — Jay's training-only exercise; not copied from Katie's maintained product documentation.</a:t>
+              <a:t>- training/operator-training-book.json — training-only exercise; not copied from Katie's maintained product documentation.</a:t>
             </a:r>
           </a:p>
         </p:txBody>
@@ -819,7 +819,7 @@
   </p:cSld>
   <p:clrMap bg1="lt1" tx1="dk1" bg2="lt2" tx2="dk2" accent1="accent1" accent2="accent2" accent3="accent3" accent4="accent4" accent5="accent5" accent6="accent6" hlink="hlink" folHlink="folHlink"/>
   <p:sldLayoutIdLst>
-    <p:sldLayoutId xmlns:r="http://schemas.openxmlformats.org/officeDocument/2006/relationships" id="2147483649" r:id="Ra24aef76942342ad"/>
+    <p:sldLayoutId xmlns:r="http://schemas.openxmlformats.org/officeDocument/2006/relationships" id="2147483649" r:id="R82cea58875054966"/>
   </p:sldLayoutIdLst>
   <p:txStyles>
     <p:titleStyle>
@@ -1370,7 +1370,7 @@
           <p:cNvPr id="4" name="eyebrow">
             <a:extLst xmlns:a="http://schemas.openxmlformats.org/drawingml/2006/main">
               <a:ext uri="{FF2B5EF4-FFF2-40B4-BE49-F238E27FC236}">
-                <a16:creationId xmlns:a16="http://schemas.microsoft.com/office/drawing/2014/main" id="{70884680-37E6-49F9-821E-BEB9A4BE11AD}"/>
+                <a16:creationId xmlns:a16="http://schemas.microsoft.com/office/drawing/2014/main" id="{F95955F9-4D04-4C6D-B77E-ABC84B8278C3}"/>
               </a:ext>
             </a:extLst>
           </p:cNvPr>
@@ -1420,7 +1420,7 @@
           <p:cNvPr id="2" name="deck-title">
             <a:extLst xmlns:a="http://schemas.openxmlformats.org/drawingml/2006/main">
               <a:ext uri="{FF2B5EF4-FFF2-40B4-BE49-F238E27FC236}">
-                <a16:creationId xmlns:a16="http://schemas.microsoft.com/office/drawing/2014/main" id="{03C5A291-CA7B-4820-967B-36B5A38B2F7F}"/>
+                <a16:creationId xmlns:a16="http://schemas.microsoft.com/office/drawing/2014/main" id="{60150ED9-86DB-48D6-B9CB-4D8C572A16C6}"/>
               </a:ext>
             </a:extLst>
           </p:cNvPr>
@@ -1470,7 +1470,7 @@
           <p:cNvPr id="3" name="deck-subtitle">
             <a:extLst xmlns:a="http://schemas.openxmlformats.org/drawingml/2006/main">
               <a:ext uri="{FF2B5EF4-FFF2-40B4-BE49-F238E27FC236}">
-                <a16:creationId xmlns:a16="http://schemas.microsoft.com/office/drawing/2014/main" id="{AF76D9F3-D887-4D94-AACB-1354E528980F}"/>
+                <a16:creationId xmlns:a16="http://schemas.microsoft.com/office/drawing/2014/main" id="{E560EBBA-4BCC-476D-BB4A-3FBEB79F445B}"/>
               </a:ext>
             </a:extLst>
           </p:cNvPr>
@@ -1518,7 +1518,7 @@
     </p:spTree>
     <p:extLst>
       <p:ext uri="{BB962C8B-B14F-4D97-AF65-F5344CB8AC3E}">
-        <p14:creationId xmlns:p14="http://schemas.microsoft.com/office/powerpoint/2010/main" val="395833697"/>
+        <p14:creationId xmlns:p14="http://schemas.microsoft.com/office/powerpoint/2010/main" val="1628844929"/>
       </p:ext>
     </p:extLst>
   </p:cSld>
@@ -1549,7 +1549,7 @@
           <p:cNvPr id="10" name="slide-2-title">
             <a:extLst xmlns:a="http://schemas.openxmlformats.org/drawingml/2006/main">
               <a:ext uri="{FF2B5EF4-FFF2-40B4-BE49-F238E27FC236}">
-                <a16:creationId xmlns:a16="http://schemas.microsoft.com/office/drawing/2014/main" id="{E2A2C32F-B7B8-45D8-8333-3B33F297348C}"/>
+                <a16:creationId xmlns:a16="http://schemas.microsoft.com/office/drawing/2014/main" id="{16350A0C-5783-4635-BD24-87B1676ED3FF}"/>
               </a:ext>
             </a:extLst>
           </p:cNvPr>
@@ -1599,7 +1599,7 @@
           <p:cNvPr id="2" name="slide-2-rule">
             <a:extLst xmlns:a="http://schemas.openxmlformats.org/drawingml/2006/main">
               <a:ext uri="{FF2B5EF4-FFF2-40B4-BE49-F238E27FC236}">
-                <a16:creationId xmlns:a16="http://schemas.microsoft.com/office/drawing/2014/main" id="{BDCE2C50-D0AB-4FEF-93CD-EDB90E70D8EA}"/>
+                <a16:creationId xmlns:a16="http://schemas.microsoft.com/office/drawing/2014/main" id="{0C0731B2-1EDA-4BC1-B03C-C209E57AB3B1}"/>
               </a:ext>
             </a:extLst>
           </p:cNvPr>
@@ -1630,7 +1630,7 @@
           <p:cNvPr id="3" name="slide-2-item-1">
             <a:extLst xmlns:a="http://schemas.openxmlformats.org/drawingml/2006/main">
               <a:ext uri="{FF2B5EF4-FFF2-40B4-BE49-F238E27FC236}">
-                <a16:creationId xmlns:a16="http://schemas.microsoft.com/office/drawing/2014/main" id="{0360452C-2DB0-49ED-8718-1AA3AD000A17}"/>
+                <a16:creationId xmlns:a16="http://schemas.microsoft.com/office/drawing/2014/main" id="{CFF456B1-8FC9-472A-81D5-EB2F994E750B}"/>
               </a:ext>
             </a:extLst>
           </p:cNvPr>
@@ -1680,7 +1680,7 @@
           <p:cNvPr id="4" name="slide-2-item-2">
             <a:extLst xmlns:a="http://schemas.openxmlformats.org/drawingml/2006/main">
               <a:ext uri="{FF2B5EF4-FFF2-40B4-BE49-F238E27FC236}">
-                <a16:creationId xmlns:a16="http://schemas.microsoft.com/office/drawing/2014/main" id="{8E4E9CD9-C49C-4D1B-BE46-BFC3EDA83522}"/>
+                <a16:creationId xmlns:a16="http://schemas.microsoft.com/office/drawing/2014/main" id="{4225F844-F44E-4AC5-801B-79018E1617A6}"/>
               </a:ext>
             </a:extLst>
           </p:cNvPr>
@@ -1730,7 +1730,7 @@
           <p:cNvPr id="5" name="slide-2-item-3">
             <a:extLst xmlns:a="http://schemas.openxmlformats.org/drawingml/2006/main">
               <a:ext uri="{FF2B5EF4-FFF2-40B4-BE49-F238E27FC236}">
-                <a16:creationId xmlns:a16="http://schemas.microsoft.com/office/drawing/2014/main" id="{02C4E24C-68EF-4F6C-BCEF-4D79B5F087EE}"/>
+                <a16:creationId xmlns:a16="http://schemas.microsoft.com/office/drawing/2014/main" id="{697DFB2D-D8CF-4262-B96D-35BCD697C510}"/>
               </a:ext>
             </a:extLst>
           </p:cNvPr>
@@ -1780,7 +1780,7 @@
           <p:cNvPr id="6" name="slide-2-item-4">
             <a:extLst xmlns:a="http://schemas.openxmlformats.org/drawingml/2006/main">
               <a:ext uri="{FF2B5EF4-FFF2-40B4-BE49-F238E27FC236}">
-                <a16:creationId xmlns:a16="http://schemas.microsoft.com/office/drawing/2014/main" id="{06357A40-68FB-43B1-A6E2-9619FEF23B55}"/>
+                <a16:creationId xmlns:a16="http://schemas.microsoft.com/office/drawing/2014/main" id="{64B2668D-B461-4F1A-AB89-B235E1C6B8E0}"/>
               </a:ext>
             </a:extLst>
           </p:cNvPr>
@@ -1830,7 +1830,7 @@
           <p:cNvPr id="7" name="slide-2-item-5">
             <a:extLst xmlns:a="http://schemas.openxmlformats.org/drawingml/2006/main">
               <a:ext uri="{FF2B5EF4-FFF2-40B4-BE49-F238E27FC236}">
-                <a16:creationId xmlns:a16="http://schemas.microsoft.com/office/drawing/2014/main" id="{9B08A308-2BBD-419A-AC5A-CAC65A200806}"/>
+                <a16:creationId xmlns:a16="http://schemas.microsoft.com/office/drawing/2014/main" id="{61D91152-0E15-4A89-ABF6-F6AACE1CB3D8}"/>
               </a:ext>
             </a:extLst>
           </p:cNvPr>
@@ -1880,7 +1880,7 @@
           <p:cNvPr id="8" name="slide-2-item-6">
             <a:extLst xmlns:a="http://schemas.openxmlformats.org/drawingml/2006/main">
               <a:ext uri="{FF2B5EF4-FFF2-40B4-BE49-F238E27FC236}">
-                <a16:creationId xmlns:a16="http://schemas.microsoft.com/office/drawing/2014/main" id="{84826B9B-0A9D-4675-869F-086C60461C00}"/>
+                <a16:creationId xmlns:a16="http://schemas.microsoft.com/office/drawing/2014/main" id="{84CEB993-650F-4B54-B6BC-33345547853F}"/>
               </a:ext>
             </a:extLst>
           </p:cNvPr>
@@ -1930,7 +1930,7 @@
           <p:cNvPr id="9" name="slide-2-footer">
             <a:extLst xmlns:a="http://schemas.openxmlformats.org/drawingml/2006/main">
               <a:ext uri="{FF2B5EF4-FFF2-40B4-BE49-F238E27FC236}">
-                <a16:creationId xmlns:a16="http://schemas.microsoft.com/office/drawing/2014/main" id="{C8008178-E9B3-4585-B4B6-02AF78823913}"/>
+                <a16:creationId xmlns:a16="http://schemas.microsoft.com/office/drawing/2014/main" id="{83D30E31-3184-44E5-AECE-8C6732C9153D}"/>
               </a:ext>
             </a:extLst>
           </p:cNvPr>
@@ -1978,7 +1978,7 @@
     </p:spTree>
     <p:extLst>
       <p:ext uri="{BB962C8B-B14F-4D97-AF65-F5344CB8AC3E}">
-        <p14:creationId xmlns:p14="http://schemas.microsoft.com/office/powerpoint/2010/main" val="1124520023"/>
+        <p14:creationId xmlns:p14="http://schemas.microsoft.com/office/powerpoint/2010/main" val="165455349"/>
       </p:ext>
     </p:extLst>
   </p:cSld>
@@ -2009,7 +2009,7 @@
           <p:cNvPr id="9" name="slide-3-title">
             <a:extLst xmlns:a="http://schemas.openxmlformats.org/drawingml/2006/main">
               <a:ext uri="{FF2B5EF4-FFF2-40B4-BE49-F238E27FC236}">
-                <a16:creationId xmlns:a16="http://schemas.microsoft.com/office/drawing/2014/main" id="{9BE35538-3772-4249-B596-81E1C985B24C}"/>
+                <a16:creationId xmlns:a16="http://schemas.microsoft.com/office/drawing/2014/main" id="{EDA4EF53-CCC9-46E8-B620-0107D56C09AD}"/>
               </a:ext>
             </a:extLst>
           </p:cNvPr>
@@ -2059,7 +2059,7 @@
           <p:cNvPr id="2" name="slide-3-rule">
             <a:extLst xmlns:a="http://schemas.openxmlformats.org/drawingml/2006/main">
               <a:ext uri="{FF2B5EF4-FFF2-40B4-BE49-F238E27FC236}">
-                <a16:creationId xmlns:a16="http://schemas.microsoft.com/office/drawing/2014/main" id="{45614460-E4A2-46E7-A816-A6723AEE186C}"/>
+                <a16:creationId xmlns:a16="http://schemas.microsoft.com/office/drawing/2014/main" id="{09E4E3A7-81A8-46A4-B911-C082EDF3F549}"/>
               </a:ext>
             </a:extLst>
           </p:cNvPr>
@@ -2090,7 +2090,7 @@
           <p:cNvPr id="3" name="slide-3-item-1">
             <a:extLst xmlns:a="http://schemas.openxmlformats.org/drawingml/2006/main">
               <a:ext uri="{FF2B5EF4-FFF2-40B4-BE49-F238E27FC236}">
-                <a16:creationId xmlns:a16="http://schemas.microsoft.com/office/drawing/2014/main" id="{30A259F6-4816-4DDD-AEA1-D942E917A818}"/>
+                <a16:creationId xmlns:a16="http://schemas.microsoft.com/office/drawing/2014/main" id="{C43DEB55-58D6-4FA3-9EF2-282F30E2B778}"/>
               </a:ext>
             </a:extLst>
           </p:cNvPr>
@@ -2140,7 +2140,7 @@
           <p:cNvPr id="4" name="slide-3-item-2">
             <a:extLst xmlns:a="http://schemas.openxmlformats.org/drawingml/2006/main">
               <a:ext uri="{FF2B5EF4-FFF2-40B4-BE49-F238E27FC236}">
-                <a16:creationId xmlns:a16="http://schemas.microsoft.com/office/drawing/2014/main" id="{2F6FA6F0-F946-4103-9F58-9D7BB110DD51}"/>
+                <a16:creationId xmlns:a16="http://schemas.microsoft.com/office/drawing/2014/main" id="{646FB736-64A2-4FA7-807C-29723B85230D}"/>
               </a:ext>
             </a:extLst>
           </p:cNvPr>
@@ -2190,7 +2190,7 @@
           <p:cNvPr id="5" name="slide-3-item-3">
             <a:extLst xmlns:a="http://schemas.openxmlformats.org/drawingml/2006/main">
               <a:ext uri="{FF2B5EF4-FFF2-40B4-BE49-F238E27FC236}">
-                <a16:creationId xmlns:a16="http://schemas.microsoft.com/office/drawing/2014/main" id="{AB7B20B4-B12A-49A3-ADCB-65457266C869}"/>
+                <a16:creationId xmlns:a16="http://schemas.microsoft.com/office/drawing/2014/main" id="{DFAF3D21-D76E-4E15-B80A-EB94B4FA8CCB}"/>
               </a:ext>
             </a:extLst>
           </p:cNvPr>
@@ -2240,7 +2240,7 @@
           <p:cNvPr id="6" name="slide-3-item-4">
             <a:extLst xmlns:a="http://schemas.openxmlformats.org/drawingml/2006/main">
               <a:ext uri="{FF2B5EF4-FFF2-40B4-BE49-F238E27FC236}">
-                <a16:creationId xmlns:a16="http://schemas.microsoft.com/office/drawing/2014/main" id="{FD07B7B6-4686-4460-8D4E-FB777EA7B239}"/>
+                <a16:creationId xmlns:a16="http://schemas.microsoft.com/office/drawing/2014/main" id="{9C0CAD5F-34F9-4F9C-99EE-0E15E94FAC0F}"/>
               </a:ext>
             </a:extLst>
           </p:cNvPr>
@@ -2290,7 +2290,7 @@
           <p:cNvPr id="7" name="slide-3-item-5">
             <a:extLst xmlns:a="http://schemas.openxmlformats.org/drawingml/2006/main">
               <a:ext uri="{FF2B5EF4-FFF2-40B4-BE49-F238E27FC236}">
-                <a16:creationId xmlns:a16="http://schemas.microsoft.com/office/drawing/2014/main" id="{436D55F3-F561-4F08-AA9B-19A94058AE86}"/>
+                <a16:creationId xmlns:a16="http://schemas.microsoft.com/office/drawing/2014/main" id="{F243B059-92F1-4347-AF42-C0D398DC2C97}"/>
               </a:ext>
             </a:extLst>
           </p:cNvPr>
@@ -2340,7 +2340,7 @@
           <p:cNvPr id="8" name="slide-3-footer">
             <a:extLst xmlns:a="http://schemas.openxmlformats.org/drawingml/2006/main">
               <a:ext uri="{FF2B5EF4-FFF2-40B4-BE49-F238E27FC236}">
-                <a16:creationId xmlns:a16="http://schemas.microsoft.com/office/drawing/2014/main" id="{240B6794-D10E-4E11-AA43-30C63755DF7D}"/>
+                <a16:creationId xmlns:a16="http://schemas.microsoft.com/office/drawing/2014/main" id="{416E5F78-EA07-4CF3-A2D5-CBA0F0D13E0E}"/>
               </a:ext>
             </a:extLst>
           </p:cNvPr>
@@ -2388,7 +2388,7 @@
     </p:spTree>
     <p:extLst>
       <p:ext uri="{BB962C8B-B14F-4D97-AF65-F5344CB8AC3E}">
-        <p14:creationId xmlns:p14="http://schemas.microsoft.com/office/powerpoint/2010/main" val="1172898338"/>
+        <p14:creationId xmlns:p14="http://schemas.microsoft.com/office/powerpoint/2010/main" val="167220162"/>
       </p:ext>
     </p:extLst>
   </p:cSld>
@@ -2419,7 +2419,7 @@
           <p:cNvPr id="10" name="slide-4-title">
             <a:extLst xmlns:a="http://schemas.openxmlformats.org/drawingml/2006/main">
               <a:ext uri="{FF2B5EF4-FFF2-40B4-BE49-F238E27FC236}">
-                <a16:creationId xmlns:a16="http://schemas.microsoft.com/office/drawing/2014/main" id="{45BB9C94-E7DE-4AD4-A90F-1866A8AF401A}"/>
+                <a16:creationId xmlns:a16="http://schemas.microsoft.com/office/drawing/2014/main" id="{838B7B4F-6B35-44FB-8647-95C9E9E76D4F}"/>
               </a:ext>
             </a:extLst>
           </p:cNvPr>
@@ -2469,7 +2469,7 @@
           <p:cNvPr id="2" name="slide-4-rule">
             <a:extLst xmlns:a="http://schemas.openxmlformats.org/drawingml/2006/main">
               <a:ext uri="{FF2B5EF4-FFF2-40B4-BE49-F238E27FC236}">
-                <a16:creationId xmlns:a16="http://schemas.microsoft.com/office/drawing/2014/main" id="{7DE1364E-1892-42DB-A0B5-E19803E91E6E}"/>
+                <a16:creationId xmlns:a16="http://schemas.microsoft.com/office/drawing/2014/main" id="{3AEBFF1A-340F-4179-A0A9-0D7925A59732}"/>
               </a:ext>
             </a:extLst>
           </p:cNvPr>
@@ -2500,7 +2500,7 @@
           <p:cNvPr id="3" name="slide-4-item-1">
             <a:extLst xmlns:a="http://schemas.openxmlformats.org/drawingml/2006/main">
               <a:ext uri="{FF2B5EF4-FFF2-40B4-BE49-F238E27FC236}">
-                <a16:creationId xmlns:a16="http://schemas.microsoft.com/office/drawing/2014/main" id="{B4973233-A950-417D-8EB1-08CC473B0C4F}"/>
+                <a16:creationId xmlns:a16="http://schemas.microsoft.com/office/drawing/2014/main" id="{CF4AB651-E9BA-4DD0-929A-747282DED40D}"/>
               </a:ext>
             </a:extLst>
           </p:cNvPr>
@@ -2550,7 +2550,7 @@
           <p:cNvPr id="4" name="slide-4-item-2">
             <a:extLst xmlns:a="http://schemas.openxmlformats.org/drawingml/2006/main">
               <a:ext uri="{FF2B5EF4-FFF2-40B4-BE49-F238E27FC236}">
-                <a16:creationId xmlns:a16="http://schemas.microsoft.com/office/drawing/2014/main" id="{9534A9E9-2919-4E74-9751-A46B5204AC95}"/>
+                <a16:creationId xmlns:a16="http://schemas.microsoft.com/office/drawing/2014/main" id="{586CFFF8-0D62-48CA-96A1-AAA5265D1108}"/>
               </a:ext>
             </a:extLst>
           </p:cNvPr>
@@ -2600,7 +2600,7 @@
           <p:cNvPr id="5" name="slide-4-item-3">
             <a:extLst xmlns:a="http://schemas.openxmlformats.org/drawingml/2006/main">
               <a:ext uri="{FF2B5EF4-FFF2-40B4-BE49-F238E27FC236}">
-                <a16:creationId xmlns:a16="http://schemas.microsoft.com/office/drawing/2014/main" id="{D190EA01-C10A-4135-BF38-809083CD11B4}"/>
+                <a16:creationId xmlns:a16="http://schemas.microsoft.com/office/drawing/2014/main" id="{2C399A17-980B-41DA-9DB6-E1B52654C41E}"/>
               </a:ext>
             </a:extLst>
           </p:cNvPr>
@@ -2650,7 +2650,7 @@
           <p:cNvPr id="6" name="slide-4-item-4">
             <a:extLst xmlns:a="http://schemas.openxmlformats.org/drawingml/2006/main">
               <a:ext uri="{FF2B5EF4-FFF2-40B4-BE49-F238E27FC236}">
-                <a16:creationId xmlns:a16="http://schemas.microsoft.com/office/drawing/2014/main" id="{AD031A42-D9BF-42C0-8427-6D273219AEEF}"/>
+                <a16:creationId xmlns:a16="http://schemas.microsoft.com/office/drawing/2014/main" id="{BFC57C08-3F3A-45DC-94CA-72A97A45347D}"/>
               </a:ext>
             </a:extLst>
           </p:cNvPr>
@@ -2700,7 +2700,7 @@
           <p:cNvPr id="7" name="slide-4-item-5">
             <a:extLst xmlns:a="http://schemas.openxmlformats.org/drawingml/2006/main">
               <a:ext uri="{FF2B5EF4-FFF2-40B4-BE49-F238E27FC236}">
-                <a16:creationId xmlns:a16="http://schemas.microsoft.com/office/drawing/2014/main" id="{6E9D1688-B0BF-44E0-8968-7339C9E4FBB8}"/>
+                <a16:creationId xmlns:a16="http://schemas.microsoft.com/office/drawing/2014/main" id="{A86CBE18-78A6-4A7D-9708-A80C8AD1B3FF}"/>
               </a:ext>
             </a:extLst>
           </p:cNvPr>
@@ -2750,7 +2750,7 @@
           <p:cNvPr id="8" name="slide-4-item-6">
             <a:extLst xmlns:a="http://schemas.openxmlformats.org/drawingml/2006/main">
               <a:ext uri="{FF2B5EF4-FFF2-40B4-BE49-F238E27FC236}">
-                <a16:creationId xmlns:a16="http://schemas.microsoft.com/office/drawing/2014/main" id="{D4A117CA-BC9B-44F7-B82F-DCAEF0F84CEB}"/>
+                <a16:creationId xmlns:a16="http://schemas.microsoft.com/office/drawing/2014/main" id="{E31C6BFD-C703-4703-AD1B-64BA38CF69C8}"/>
               </a:ext>
             </a:extLst>
           </p:cNvPr>
@@ -2800,7 +2800,7 @@
           <p:cNvPr id="9" name="slide-4-footer">
             <a:extLst xmlns:a="http://schemas.openxmlformats.org/drawingml/2006/main">
               <a:ext uri="{FF2B5EF4-FFF2-40B4-BE49-F238E27FC236}">
-                <a16:creationId xmlns:a16="http://schemas.microsoft.com/office/drawing/2014/main" id="{2E96FEBE-A25F-4BF3-BA41-16362395ABCD}"/>
+                <a16:creationId xmlns:a16="http://schemas.microsoft.com/office/drawing/2014/main" id="{30A9BD83-F097-47F8-8879-E61D88BE511B}"/>
               </a:ext>
             </a:extLst>
           </p:cNvPr>
@@ -2848,7 +2848,7 @@
     </p:spTree>
     <p:extLst>
       <p:ext uri="{BB962C8B-B14F-4D97-AF65-F5344CB8AC3E}">
-        <p14:creationId xmlns:p14="http://schemas.microsoft.com/office/powerpoint/2010/main" val="1388756135"/>
+        <p14:creationId xmlns:p14="http://schemas.microsoft.com/office/powerpoint/2010/main" val="1124409477"/>
       </p:ext>
     </p:extLst>
   </p:cSld>
@@ -2879,7 +2879,7 @@
           <p:cNvPr id="7" name="slide-5-title">
             <a:extLst xmlns:a="http://schemas.openxmlformats.org/drawingml/2006/main">
               <a:ext uri="{FF2B5EF4-FFF2-40B4-BE49-F238E27FC236}">
-                <a16:creationId xmlns:a16="http://schemas.microsoft.com/office/drawing/2014/main" id="{B74A3FF2-3D1A-4825-89AF-4F0296C30EBC}"/>
+                <a16:creationId xmlns:a16="http://schemas.microsoft.com/office/drawing/2014/main" id="{1E33F23D-7E10-46D6-B223-1C243EEB2F65}"/>
               </a:ext>
             </a:extLst>
           </p:cNvPr>
@@ -2929,7 +2929,7 @@
           <p:cNvPr id="2" name="slide-5-rule">
             <a:extLst xmlns:a="http://schemas.openxmlformats.org/drawingml/2006/main">
               <a:ext uri="{FF2B5EF4-FFF2-40B4-BE49-F238E27FC236}">
-                <a16:creationId xmlns:a16="http://schemas.microsoft.com/office/drawing/2014/main" id="{B902D861-C07C-437C-BCDD-5E4370D989D6}"/>
+                <a16:creationId xmlns:a16="http://schemas.microsoft.com/office/drawing/2014/main" id="{0FAECF0E-B2EE-4F57-9F5C-74E5F53DE02A}"/>
               </a:ext>
             </a:extLst>
           </p:cNvPr>
@@ -2960,7 +2960,7 @@
           <p:cNvPr id="3" name="slide-5-item-1">
             <a:extLst xmlns:a="http://schemas.openxmlformats.org/drawingml/2006/main">
               <a:ext uri="{FF2B5EF4-FFF2-40B4-BE49-F238E27FC236}">
-                <a16:creationId xmlns:a16="http://schemas.microsoft.com/office/drawing/2014/main" id="{78839901-8431-4336-8E6B-67888B75EED7}"/>
+                <a16:creationId xmlns:a16="http://schemas.microsoft.com/office/drawing/2014/main" id="{767602E3-54C7-4B37-AA8F-E31E2F5FF33C}"/>
               </a:ext>
             </a:extLst>
           </p:cNvPr>
@@ -3010,7 +3010,7 @@
           <p:cNvPr id="4" name="slide-5-item-2">
             <a:extLst xmlns:a="http://schemas.openxmlformats.org/drawingml/2006/main">
               <a:ext uri="{FF2B5EF4-FFF2-40B4-BE49-F238E27FC236}">
-                <a16:creationId xmlns:a16="http://schemas.microsoft.com/office/drawing/2014/main" id="{D3F42FC7-15ED-4EFD-A893-D674E4DBF6C1}"/>
+                <a16:creationId xmlns:a16="http://schemas.microsoft.com/office/drawing/2014/main" id="{A2F1EF1D-CD9A-4BDB-989A-3CA77939E8FF}"/>
               </a:ext>
             </a:extLst>
           </p:cNvPr>
@@ -3060,7 +3060,7 @@
           <p:cNvPr id="5" name="slide-5-item-3">
             <a:extLst xmlns:a="http://schemas.openxmlformats.org/drawingml/2006/main">
               <a:ext uri="{FF2B5EF4-FFF2-40B4-BE49-F238E27FC236}">
-                <a16:creationId xmlns:a16="http://schemas.microsoft.com/office/drawing/2014/main" id="{3F347672-2EC5-4698-B61C-ADB38F39A289}"/>
+                <a16:creationId xmlns:a16="http://schemas.microsoft.com/office/drawing/2014/main" id="{08A567B4-D7E0-4EE3-8C19-724BF863B1A8}"/>
               </a:ext>
             </a:extLst>
           </p:cNvPr>
@@ -3110,7 +3110,7 @@
           <p:cNvPr id="6" name="slide-5-footer">
             <a:extLst xmlns:a="http://schemas.openxmlformats.org/drawingml/2006/main">
               <a:ext uri="{FF2B5EF4-FFF2-40B4-BE49-F238E27FC236}">
-                <a16:creationId xmlns:a16="http://schemas.microsoft.com/office/drawing/2014/main" id="{F18C1794-893E-4A8F-B1CA-F62D7D144BC8}"/>
+                <a16:creationId xmlns:a16="http://schemas.microsoft.com/office/drawing/2014/main" id="{5EB7A055-61F5-4957-A5F8-9167ECE179B9}"/>
               </a:ext>
             </a:extLst>
           </p:cNvPr>
@@ -3158,7 +3158,7 @@
     </p:spTree>
     <p:extLst>
       <p:ext uri="{BB962C8B-B14F-4D97-AF65-F5344CB8AC3E}">
-        <p14:creationId xmlns:p14="http://schemas.microsoft.com/office/powerpoint/2010/main" val="462300185"/>
+        <p14:creationId xmlns:p14="http://schemas.microsoft.com/office/powerpoint/2010/main" val="1541316129"/>
       </p:ext>
     </p:extLst>
   </p:cSld>

</xml_diff>